<commit_message>
Include QR code for lesson
</commit_message>
<xml_diff>
--- a/powerpoints/profile_optimise_py.pptx
+++ b/powerpoints/profile_optimise_py.pptx
@@ -127,9 +127,142 @@
 <file path=ppt/revisionInfo.xml><?xml version="1.0" encoding="utf-8"?>
 <p1510:revInfo xmlns:a="http://schemas.openxmlformats.org/drawingml/2006/main" xmlns:r="http://schemas.openxmlformats.org/officeDocument/2006/relationships" xmlns:p1510="http://schemas.microsoft.com/office/powerpoint/2015/10/main">
   <p1510:revLst>
-    <p1510:client id="{CF4CA8C3-8BC7-40F0-9397-742F3016F6D7}" v="1" dt="2026-03-31T12:59:33.406"/>
+    <p1510:client id="{CF4CA8C3-8BC7-40F0-9397-742F3016F6D7}" v="8" dt="2026-04-13T14:16:55.141"/>
   </p1510:revLst>
 </p1510:revInfo>
+</file>
+
+<file path=ppt/changesInfos/changesInfo1.xml><?xml version="1.0" encoding="utf-8"?>
+<pc:chgInfo xmlns:a="http://schemas.openxmlformats.org/drawingml/2006/main" xmlns:r="http://schemas.openxmlformats.org/officeDocument/2006/relationships" xmlns:ac="http://schemas.microsoft.com/office/drawing/2013/main/command" xmlns:pc="http://schemas.microsoft.com/office/powerpoint/2013/main/command">
+  <pc:docChgLst>
+    <pc:chgData name="Bhogal, Saranjeet Kaur S S" userId="2fe8569c-4c6c-4052-8fd2-44af4b611544" providerId="ADAL" clId="{1D98CA10-CBF0-46F0-A4EA-0A6C85047680}"/>
+    <pc:docChg chg="undo custSel modSld">
+      <pc:chgData name="Bhogal, Saranjeet Kaur S S" userId="2fe8569c-4c6c-4052-8fd2-44af4b611544" providerId="ADAL" clId="{1D98CA10-CBF0-46F0-A4EA-0A6C85047680}" dt="2026-04-13T14:20:48.166" v="104" actId="20577"/>
+      <pc:docMkLst>
+        <pc:docMk/>
+      </pc:docMkLst>
+      <pc:sldChg chg="addSp modSp mod">
+        <pc:chgData name="Bhogal, Saranjeet Kaur S S" userId="2fe8569c-4c6c-4052-8fd2-44af4b611544" providerId="ADAL" clId="{1D98CA10-CBF0-46F0-A4EA-0A6C85047680}" dt="2026-04-13T14:20:48.166" v="104" actId="20577"/>
+        <pc:sldMkLst>
+          <pc:docMk/>
+          <pc:sldMk cId="3954101926" sldId="265"/>
+        </pc:sldMkLst>
+        <pc:spChg chg="mod">
+          <ac:chgData name="Bhogal, Saranjeet Kaur S S" userId="2fe8569c-4c6c-4052-8fd2-44af4b611544" providerId="ADAL" clId="{1D98CA10-CBF0-46F0-A4EA-0A6C85047680}" dt="2026-04-13T14:20:48.166" v="104" actId="20577"/>
+          <ac:spMkLst>
+            <pc:docMk/>
+            <pc:sldMk cId="3954101926" sldId="265"/>
+            <ac:spMk id="2" creationId="{82A7943A-7AB9-426C-B701-AB3F40BC3E55}"/>
+          </ac:spMkLst>
+        </pc:spChg>
+        <pc:spChg chg="add mod">
+          <ac:chgData name="Bhogal, Saranjeet Kaur S S" userId="2fe8569c-4c6c-4052-8fd2-44af4b611544" providerId="ADAL" clId="{1D98CA10-CBF0-46F0-A4EA-0A6C85047680}" dt="2026-04-13T14:20:29.223" v="102" actId="207"/>
+          <ac:spMkLst>
+            <pc:docMk/>
+            <pc:sldMk cId="3954101926" sldId="265"/>
+            <ac:spMk id="4" creationId="{E0F31A31-CD6E-BEFE-A329-F4F2C4DB79CB}"/>
+          </ac:spMkLst>
+        </pc:spChg>
+        <pc:spChg chg="mod">
+          <ac:chgData name="Bhogal, Saranjeet Kaur S S" userId="2fe8569c-4c6c-4052-8fd2-44af4b611544" providerId="ADAL" clId="{1D98CA10-CBF0-46F0-A4EA-0A6C85047680}" dt="2026-03-31T12:59:33.399" v="0"/>
+          <ac:spMkLst>
+            <pc:docMk/>
+            <pc:sldMk cId="3954101926" sldId="265"/>
+            <ac:spMk id="543" creationId="{E4FDDDDC-F0DD-374A-74A3-E8B13296330F}"/>
+          </ac:spMkLst>
+        </pc:spChg>
+        <pc:spChg chg="mod">
+          <ac:chgData name="Bhogal, Saranjeet Kaur S S" userId="2fe8569c-4c6c-4052-8fd2-44af4b611544" providerId="ADAL" clId="{1D98CA10-CBF0-46F0-A4EA-0A6C85047680}" dt="2026-03-31T13:00:14.835" v="1" actId="1076"/>
+          <ac:spMkLst>
+            <pc:docMk/>
+            <pc:sldMk cId="3954101926" sldId="265"/>
+            <ac:spMk id="556" creationId="{AF72284D-F14A-0274-FA05-46DA36EB85E7}"/>
+          </ac:spMkLst>
+        </pc:spChg>
+        <pc:spChg chg="mod">
+          <ac:chgData name="Bhogal, Saranjeet Kaur S S" userId="2fe8569c-4c6c-4052-8fd2-44af4b611544" providerId="ADAL" clId="{1D98CA10-CBF0-46F0-A4EA-0A6C85047680}" dt="2026-03-31T13:00:14.835" v="1" actId="1076"/>
+          <ac:spMkLst>
+            <pc:docMk/>
+            <pc:sldMk cId="3954101926" sldId="265"/>
+            <ac:spMk id="559" creationId="{808DCF4F-D73A-6B88-57AF-47FF0CEC8345}"/>
+          </ac:spMkLst>
+        </pc:spChg>
+        <pc:spChg chg="mod">
+          <ac:chgData name="Bhogal, Saranjeet Kaur S S" userId="2fe8569c-4c6c-4052-8fd2-44af4b611544" providerId="ADAL" clId="{1D98CA10-CBF0-46F0-A4EA-0A6C85047680}" dt="2026-03-31T13:00:14.835" v="1" actId="1076"/>
+          <ac:spMkLst>
+            <pc:docMk/>
+            <pc:sldMk cId="3954101926" sldId="265"/>
+            <ac:spMk id="563" creationId="{E51B9BB8-0F15-4B57-E465-C1CC57252606}"/>
+          </ac:spMkLst>
+        </pc:spChg>
+        <pc:picChg chg="mod">
+          <ac:chgData name="Bhogal, Saranjeet Kaur S S" userId="2fe8569c-4c6c-4052-8fd2-44af4b611544" providerId="ADAL" clId="{1D98CA10-CBF0-46F0-A4EA-0A6C85047680}" dt="2026-03-31T13:00:14.835" v="1" actId="1076"/>
+          <ac:picMkLst>
+            <pc:docMk/>
+            <pc:sldMk cId="3954101926" sldId="265"/>
+            <ac:picMk id="573" creationId="{DCB98A4D-10FB-803A-9E51-390463BB1551}"/>
+          </ac:picMkLst>
+        </pc:picChg>
+        <pc:picChg chg="mod">
+          <ac:chgData name="Bhogal, Saranjeet Kaur S S" userId="2fe8569c-4c6c-4052-8fd2-44af4b611544" providerId="ADAL" clId="{1D98CA10-CBF0-46F0-A4EA-0A6C85047680}" dt="2026-03-31T13:00:14.835" v="1" actId="1076"/>
+          <ac:picMkLst>
+            <pc:docMk/>
+            <pc:sldMk cId="3954101926" sldId="265"/>
+            <ac:picMk id="574" creationId="{16A9180B-CF64-53AD-FD84-182A8332991E}"/>
+          </ac:picMkLst>
+        </pc:picChg>
+        <pc:picChg chg="mod">
+          <ac:chgData name="Bhogal, Saranjeet Kaur S S" userId="2fe8569c-4c6c-4052-8fd2-44af4b611544" providerId="ADAL" clId="{1D98CA10-CBF0-46F0-A4EA-0A6C85047680}" dt="2026-03-31T13:00:14.835" v="1" actId="1076"/>
+          <ac:picMkLst>
+            <pc:docMk/>
+            <pc:sldMk cId="3954101926" sldId="265"/>
+            <ac:picMk id="575" creationId="{FCB533D4-43B0-0E47-D85C-3A4972E8D5BA}"/>
+          </ac:picMkLst>
+        </pc:picChg>
+        <pc:picChg chg="add mod">
+          <ac:chgData name="Bhogal, Saranjeet Kaur S S" userId="2fe8569c-4c6c-4052-8fd2-44af4b611544" providerId="ADAL" clId="{1D98CA10-CBF0-46F0-A4EA-0A6C85047680}" dt="2026-04-13T14:16:35.622" v="7" actId="1076"/>
+          <ac:picMkLst>
+            <pc:docMk/>
+            <pc:sldMk cId="3954101926" sldId="265"/>
+            <ac:picMk id="1026" creationId="{790B0E03-9810-9519-9B7F-BFB6D97A4824}"/>
+          </ac:picMkLst>
+        </pc:picChg>
+        <pc:cxnChg chg="mod">
+          <ac:chgData name="Bhogal, Saranjeet Kaur S S" userId="2fe8569c-4c6c-4052-8fd2-44af4b611544" providerId="ADAL" clId="{1D98CA10-CBF0-46F0-A4EA-0A6C85047680}" dt="2026-03-31T13:00:14.835" v="1" actId="1076"/>
+          <ac:cxnSpMkLst>
+            <pc:docMk/>
+            <pc:sldMk cId="3954101926" sldId="265"/>
+            <ac:cxnSpMk id="544" creationId="{C164BBDA-59F4-95C1-46E7-88B6530A52FD}"/>
+          </ac:cxnSpMkLst>
+        </pc:cxnChg>
+        <pc:cxnChg chg="mod">
+          <ac:chgData name="Bhogal, Saranjeet Kaur S S" userId="2fe8569c-4c6c-4052-8fd2-44af4b611544" providerId="ADAL" clId="{1D98CA10-CBF0-46F0-A4EA-0A6C85047680}" dt="2026-03-31T13:00:14.835" v="1" actId="1076"/>
+          <ac:cxnSpMkLst>
+            <pc:docMk/>
+            <pc:sldMk cId="3954101926" sldId="265"/>
+            <ac:cxnSpMk id="557" creationId="{1A99DE71-91A0-E7E5-186D-E4EFC465C3F1}"/>
+          </ac:cxnSpMkLst>
+        </pc:cxnChg>
+        <pc:cxnChg chg="mod">
+          <ac:chgData name="Bhogal, Saranjeet Kaur S S" userId="2fe8569c-4c6c-4052-8fd2-44af4b611544" providerId="ADAL" clId="{1D98CA10-CBF0-46F0-A4EA-0A6C85047680}" dt="2026-03-31T13:00:14.835" v="1" actId="1076"/>
+          <ac:cxnSpMkLst>
+            <pc:docMk/>
+            <pc:sldMk cId="3954101926" sldId="265"/>
+            <ac:cxnSpMk id="562" creationId="{36184654-5E52-0423-F412-AA9DCA2D2552}"/>
+          </ac:cxnSpMkLst>
+        </pc:cxnChg>
+        <pc:cxnChg chg="mod">
+          <ac:chgData name="Bhogal, Saranjeet Kaur S S" userId="2fe8569c-4c6c-4052-8fd2-44af4b611544" providerId="ADAL" clId="{1D98CA10-CBF0-46F0-A4EA-0A6C85047680}" dt="2026-03-31T13:00:14.835" v="1" actId="1076"/>
+          <ac:cxnSpMkLst>
+            <pc:docMk/>
+            <pc:sldMk cId="3954101926" sldId="265"/>
+            <ac:cxnSpMk id="564" creationId="{FBF06C40-2171-D5EC-6422-1A6F89E1F86A}"/>
+          </ac:cxnSpMkLst>
+        </pc:cxnChg>
+      </pc:sldChg>
+    </pc:docChg>
+  </pc:docChgLst>
+</pc:chgInfo>
 </file>
 
 <file path=ppt/slideLayouts/slideLayout1.xml><?xml version="1.0" encoding="utf-8"?>
@@ -261,7 +394,7 @@
           <a:p>
             <a:fld id="{1F0D46D8-BD22-47A1-BD7A-07A5FE3E416C}" type="datetimeFigureOut">
               <a:rPr lang="en-US" smtClean="0"/>
-              <a:t>3/31/2026</a:t>
+              <a:t>4/13/2026</a:t>
             </a:fld>
             <a:endParaRPr lang="en-US"/>
           </a:p>
@@ -429,7 +562,7 @@
           <a:p>
             <a:fld id="{1F0D46D8-BD22-47A1-BD7A-07A5FE3E416C}" type="datetimeFigureOut">
               <a:rPr lang="en-US" smtClean="0"/>
-              <a:t>3/31/2026</a:t>
+              <a:t>4/13/2026</a:t>
             </a:fld>
             <a:endParaRPr lang="en-US"/>
           </a:p>
@@ -607,7 +740,7 @@
           <a:p>
             <a:fld id="{1F0D46D8-BD22-47A1-BD7A-07A5FE3E416C}" type="datetimeFigureOut">
               <a:rPr lang="en-US" smtClean="0"/>
-              <a:t>3/31/2026</a:t>
+              <a:t>4/13/2026</a:t>
             </a:fld>
             <a:endParaRPr lang="en-US"/>
           </a:p>
@@ -775,7 +908,7 @@
           <a:p>
             <a:fld id="{1F0D46D8-BD22-47A1-BD7A-07A5FE3E416C}" type="datetimeFigureOut">
               <a:rPr lang="en-US" smtClean="0"/>
-              <a:t>3/31/2026</a:t>
+              <a:t>4/13/2026</a:t>
             </a:fld>
             <a:endParaRPr lang="en-US"/>
           </a:p>
@@ -1020,7 +1153,7 @@
           <a:p>
             <a:fld id="{1F0D46D8-BD22-47A1-BD7A-07A5FE3E416C}" type="datetimeFigureOut">
               <a:rPr lang="en-US" smtClean="0"/>
-              <a:t>3/31/2026</a:t>
+              <a:t>4/13/2026</a:t>
             </a:fld>
             <a:endParaRPr lang="en-US"/>
           </a:p>
@@ -1249,7 +1382,7 @@
           <a:p>
             <a:fld id="{1F0D46D8-BD22-47A1-BD7A-07A5FE3E416C}" type="datetimeFigureOut">
               <a:rPr lang="en-US" smtClean="0"/>
-              <a:t>3/31/2026</a:t>
+              <a:t>4/13/2026</a:t>
             </a:fld>
             <a:endParaRPr lang="en-US"/>
           </a:p>
@@ -1613,7 +1746,7 @@
           <a:p>
             <a:fld id="{1F0D46D8-BD22-47A1-BD7A-07A5FE3E416C}" type="datetimeFigureOut">
               <a:rPr lang="en-US" smtClean="0"/>
-              <a:t>3/31/2026</a:t>
+              <a:t>4/13/2026</a:t>
             </a:fld>
             <a:endParaRPr lang="en-US"/>
           </a:p>
@@ -1730,7 +1863,7 @@
           <a:p>
             <a:fld id="{1F0D46D8-BD22-47A1-BD7A-07A5FE3E416C}" type="datetimeFigureOut">
               <a:rPr lang="en-US" smtClean="0"/>
-              <a:t>3/31/2026</a:t>
+              <a:t>4/13/2026</a:t>
             </a:fld>
             <a:endParaRPr lang="en-US"/>
           </a:p>
@@ -1825,7 +1958,7 @@
           <a:p>
             <a:fld id="{1F0D46D8-BD22-47A1-BD7A-07A5FE3E416C}" type="datetimeFigureOut">
               <a:rPr lang="en-US" smtClean="0"/>
-              <a:t>3/31/2026</a:t>
+              <a:t>4/13/2026</a:t>
             </a:fld>
             <a:endParaRPr lang="en-US"/>
           </a:p>
@@ -2100,7 +2233,7 @@
           <a:p>
             <a:fld id="{1F0D46D8-BD22-47A1-BD7A-07A5FE3E416C}" type="datetimeFigureOut">
               <a:rPr lang="en-US" smtClean="0"/>
-              <a:t>3/31/2026</a:t>
+              <a:t>4/13/2026</a:t>
             </a:fld>
             <a:endParaRPr lang="en-US"/>
           </a:p>
@@ -2355,7 +2488,7 @@
           <a:p>
             <a:fld id="{1F0D46D8-BD22-47A1-BD7A-07A5FE3E416C}" type="datetimeFigureOut">
               <a:rPr lang="en-US" smtClean="0"/>
-              <a:t>3/31/2026</a:t>
+              <a:t>4/13/2026</a:t>
             </a:fld>
             <a:endParaRPr lang="en-US"/>
           </a:p>
@@ -2566,7 +2699,7 @@
           <a:p>
             <a:fld id="{1F0D46D8-BD22-47A1-BD7A-07A5FE3E416C}" type="datetimeFigureOut">
               <a:rPr lang="en-US" smtClean="0"/>
-              <a:t>3/31/2026</a:t>
+              <a:t>4/13/2026</a:t>
             </a:fld>
             <a:endParaRPr lang="en-US"/>
           </a:p>
@@ -10133,7 +10266,7 @@
           </a:ln>
           <a:extLst>
             <a:ext uri="{C572A759-6A51-4108-AA02-DFA0A04FC94B}">
-              <ma14:wrappingTextBoxFlag xmlns:m="http://schemas.openxmlformats.org/officeDocument/2006/math" xmlns:a14="http://schemas.microsoft.com/office/drawing/2010/main" xmlns:ma14="http://schemas.microsoft.com/office/mac/drawingml/2011/main" xmlns="" xmlns:lc="http://schemas.openxmlformats.org/drawingml/2006/lockedCanvas" val="1"/>
+              <ma14:wrappingTextBoxFlag xmlns:lc="http://schemas.openxmlformats.org/drawingml/2006/lockedCanvas" xmlns="" xmlns:ma14="http://schemas.microsoft.com/office/mac/drawingml/2011/main" xmlns:a14="http://schemas.microsoft.com/office/drawing/2010/main" xmlns:m="http://schemas.openxmlformats.org/officeDocument/2006/math" val="1"/>
             </a:ext>
           </a:extLst>
         </p:spPr>
@@ -10287,14 +10420,102 @@
               <a:t>26</a:t>
             </a:r>
             <a:r>
-              <a:rPr sz="1200" dirty="0"/>
+              <a:rPr sz="1200"/>
               <a:t>-</a:t>
             </a:r>
             <a:r>
-              <a:rPr lang="en-GB" sz="1200" dirty="0"/>
-              <a:t>03</a:t>
+              <a:rPr lang="en-GB" sz="1200"/>
+              <a:t>04</a:t>
             </a:r>
             <a:endParaRPr sz="1200" dirty="0"/>
+          </a:p>
+        </p:txBody>
+      </p:sp>
+      <p:pic>
+        <p:nvPicPr>
+          <p:cNvPr id="1026" name="Picture 2">
+            <a:extLst>
+              <a:ext uri="{FF2B5EF4-FFF2-40B4-BE49-F238E27FC236}">
+                <a16:creationId xmlns:a16="http://schemas.microsoft.com/office/drawing/2014/main" id="{790B0E03-9810-9519-9B7F-BFB6D97A4824}"/>
+              </a:ext>
+            </a:extLst>
+          </p:cNvPr>
+          <p:cNvPicPr>
+            <a:picLocks noChangeAspect="1" noChangeArrowheads="1"/>
+          </p:cNvPicPr>
+          <p:nvPr/>
+        </p:nvPicPr>
+        <p:blipFill>
+          <a:blip r:embed="rId47">
+            <a:extLst>
+              <a:ext uri="{28A0092B-C50C-407E-A947-70E740481C1C}">
+                <a14:useLocalDpi xmlns:a14="http://schemas.microsoft.com/office/drawing/2010/main" val="0"/>
+              </a:ext>
+            </a:extLst>
+          </a:blip>
+          <a:srcRect/>
+          <a:stretch>
+            <a:fillRect/>
+          </a:stretch>
+        </p:blipFill>
+        <p:spPr bwMode="auto">
+          <a:xfrm>
+            <a:off x="22594250" y="11911402"/>
+            <a:ext cx="1207308" cy="1207308"/>
+          </a:xfrm>
+          <a:prstGeom prst="rect">
+            <a:avLst/>
+          </a:prstGeom>
+          <a:noFill/>
+          <a:extLst>
+            <a:ext uri="{909E8E84-426E-40DD-AFC4-6F175D3DCCD1}">
+              <a14:hiddenFill xmlns:a14="http://schemas.microsoft.com/office/drawing/2010/main">
+                <a:solidFill>
+                  <a:srgbClr val="FFFFFF"/>
+                </a:solidFill>
+              </a14:hiddenFill>
+            </a:ext>
+          </a:extLst>
+        </p:spPr>
+      </p:pic>
+      <p:sp>
+        <p:nvSpPr>
+          <p:cNvPr id="4" name="TextBox 3">
+            <a:extLst>
+              <a:ext uri="{FF2B5EF4-FFF2-40B4-BE49-F238E27FC236}">
+                <a16:creationId xmlns:a16="http://schemas.microsoft.com/office/drawing/2014/main" id="{E0F31A31-CD6E-BEFE-A329-F4F2C4DB79CB}"/>
+              </a:ext>
+            </a:extLst>
+          </p:cNvPr>
+          <p:cNvSpPr txBox="1"/>
+          <p:nvPr/>
+        </p:nvSpPr>
+        <p:spPr>
+          <a:xfrm>
+            <a:off x="22510101" y="11640392"/>
+            <a:ext cx="1364553" cy="276999"/>
+          </a:xfrm>
+          <a:prstGeom prst="rect">
+            <a:avLst/>
+          </a:prstGeom>
+          <a:noFill/>
+        </p:spPr>
+        <p:txBody>
+          <a:bodyPr wrap="square" rtlCol="0">
+            <a:spAutoFit/>
+          </a:bodyPr>
+          <a:lstStyle/>
+          <a:p>
+            <a:r>
+              <a:rPr lang="en-GB" sz="1200" dirty="0">
+                <a:solidFill>
+                  <a:schemeClr val="accent2">
+                    <a:lumMod val="50000"/>
+                  </a:schemeClr>
+                </a:solidFill>
+              </a:rPr>
+              <a:t>Link to the lesson</a:t>
+            </a:r>
           </a:p>
         </p:txBody>
       </p:sp>
@@ -10540,12 +10761,16 @@
 </file>
 
 <file path=customXml/item1.xml><?xml version="1.0" encoding="utf-8"?>
-<?mso-contentType ?>
-<FormTemplates xmlns="http://schemas.microsoft.com/sharepoint/v3/contenttype/forms">
-  <Display>DocumentLibraryForm</Display>
-  <Edit>DocumentLibraryForm</Edit>
-  <New>DocumentLibraryForm</New>
-</FormTemplates>
+<p:properties xmlns:p="http://schemas.microsoft.com/office/2006/metadata/properties" xmlns:xsi="http://www.w3.org/2001/XMLSchema-instance" xmlns:pc="http://schemas.microsoft.com/office/infopath/2007/PartnerControls">
+  <documentManagement>
+    <_ip_UnifiedCompliancePolicyUIAction xmlns="http://schemas.microsoft.com/sharepoint/v3" xsi:nil="true"/>
+    <_ip_UnifiedCompliancePolicyProperties xmlns="http://schemas.microsoft.com/sharepoint/v3" xsi:nil="true"/>
+    <lcf76f155ced4ddcb4097134ff3c332f xmlns="49d1f944-d188-4381-99f4-def42f295732">
+      <Terms xmlns="http://schemas.microsoft.com/office/infopath/2007/PartnerControls"/>
+    </lcf76f155ced4ddcb4097134ff3c332f>
+    <TaxCatchAll xmlns="230e9df3-be65-4c73-a93b-d1236ebd677e" xsi:nil="true"/>
+  </documentManagement>
+</p:properties>
 </file>
 
 <file path=customXml/item2.xml><?xml version="1.0" encoding="utf-8"?>
@@ -10781,22 +11006,28 @@
 </file>
 
 <file path=customXml/item3.xml><?xml version="1.0" encoding="utf-8"?>
-<p:properties xmlns:p="http://schemas.microsoft.com/office/2006/metadata/properties" xmlns:xsi="http://www.w3.org/2001/XMLSchema-instance" xmlns:pc="http://schemas.microsoft.com/office/infopath/2007/PartnerControls">
-  <documentManagement>
-    <_ip_UnifiedCompliancePolicyUIAction xmlns="http://schemas.microsoft.com/sharepoint/v3" xsi:nil="true"/>
-    <_ip_UnifiedCompliancePolicyProperties xmlns="http://schemas.microsoft.com/sharepoint/v3" xsi:nil="true"/>
-    <lcf76f155ced4ddcb4097134ff3c332f xmlns="49d1f944-d188-4381-99f4-def42f295732">
-      <Terms xmlns="http://schemas.microsoft.com/office/infopath/2007/PartnerControls"/>
-    </lcf76f155ced4ddcb4097134ff3c332f>
-    <TaxCatchAll xmlns="230e9df3-be65-4c73-a93b-d1236ebd677e" xsi:nil="true"/>
-  </documentManagement>
-</p:properties>
+<?mso-contentType ?>
+<FormTemplates xmlns="http://schemas.microsoft.com/sharepoint/v3/contenttype/forms">
+  <Display>DocumentLibraryForm</Display>
+  <Edit>DocumentLibraryForm</Edit>
+  <New>DocumentLibraryForm</New>
+</FormTemplates>
 </file>
 
 <file path=customXml/itemProps1.xml><?xml version="1.0" encoding="utf-8"?>
-<ds:datastoreItem xmlns:ds="http://schemas.openxmlformats.org/officeDocument/2006/customXml" ds:itemID="{9D71FD8C-838C-4C60-ADA2-9C781E93CA4B}">
+<ds:datastoreItem xmlns:ds="http://schemas.openxmlformats.org/officeDocument/2006/customXml" ds:itemID="{23121672-B974-458E-BE62-3388420025F5}">
   <ds:schemaRefs>
-    <ds:schemaRef ds:uri="http://schemas.microsoft.com/sharepoint/v3/contenttype/forms"/>
+    <ds:schemaRef ds:uri="http://purl.org/dc/dcmitype/"/>
+    <ds:schemaRef ds:uri="http://schemas.microsoft.com/sharepoint/v3"/>
+    <ds:schemaRef ds:uri="http://schemas.microsoft.com/office/2006/documentManagement/types"/>
+    <ds:schemaRef ds:uri="http://schemas.microsoft.com/office/infopath/2007/PartnerControls"/>
+    <ds:schemaRef ds:uri="http://www.w3.org/XML/1998/namespace"/>
+    <ds:schemaRef ds:uri="http://schemas.openxmlformats.org/package/2006/metadata/core-properties"/>
+    <ds:schemaRef ds:uri="230e9df3-be65-4c73-a93b-d1236ebd677e"/>
+    <ds:schemaRef ds:uri="49d1f944-d188-4381-99f4-def42f295732"/>
+    <ds:schemaRef ds:uri="http://schemas.microsoft.com/office/2006/metadata/properties"/>
+    <ds:schemaRef ds:uri="http://purl.org/dc/terms/"/>
+    <ds:schemaRef ds:uri="http://purl.org/dc/elements/1.1/"/>
   </ds:schemaRefs>
 </ds:datastoreItem>
 </file>
@@ -10822,19 +11053,9 @@
 </file>
 
 <file path=customXml/itemProps3.xml><?xml version="1.0" encoding="utf-8"?>
-<ds:datastoreItem xmlns:ds="http://schemas.openxmlformats.org/officeDocument/2006/customXml" ds:itemID="{23121672-B974-458E-BE62-3388420025F5}">
+<ds:datastoreItem xmlns:ds="http://schemas.openxmlformats.org/officeDocument/2006/customXml" ds:itemID="{9D71FD8C-838C-4C60-ADA2-9C781E93CA4B}">
   <ds:schemaRefs>
-    <ds:schemaRef ds:uri="http://purl.org/dc/dcmitype/"/>
-    <ds:schemaRef ds:uri="http://schemas.microsoft.com/sharepoint/v3"/>
-    <ds:schemaRef ds:uri="http://schemas.microsoft.com/office/2006/documentManagement/types"/>
-    <ds:schemaRef ds:uri="http://schemas.microsoft.com/office/infopath/2007/PartnerControls"/>
-    <ds:schemaRef ds:uri="http://www.w3.org/XML/1998/namespace"/>
-    <ds:schemaRef ds:uri="http://schemas.openxmlformats.org/package/2006/metadata/core-properties"/>
-    <ds:schemaRef ds:uri="230e9df3-be65-4c73-a93b-d1236ebd677e"/>
-    <ds:schemaRef ds:uri="49d1f944-d188-4381-99f4-def42f295732"/>
-    <ds:schemaRef ds:uri="http://schemas.microsoft.com/office/2006/metadata/properties"/>
-    <ds:schemaRef ds:uri="http://purl.org/dc/terms/"/>
-    <ds:schemaRef ds:uri="http://purl.org/dc/elements/1.1/"/>
+    <ds:schemaRef ds:uri="http://schemas.microsoft.com/sharepoint/v3/contenttype/forms"/>
   </ds:schemaRefs>
 </ds:datastoreItem>
 </file>

</xml_diff>